<commit_message>
build: regen artifacts after MA regime change (centered → trailing)
</commit_message>
<xml_diff>
--- a/resources/office-templates/epidemic-report-template.pptx
+++ b/resources/office-templates/epidemic-report-template.pptx
@@ -3311,8 +3311,8 @@
         </p:blipFill>
         <p:spPr>
           <a:xfrm>
-            <a:off x="1744050" y="1005840"/>
-            <a:ext cx="8703595" cy="4754880"/>
+            <a:off x="1690259" y="1005840"/>
+            <a:ext cx="8811176" cy="4754880"/>
           </a:xfrm>
           <a:prstGeom prst="rect">
             <a:avLst/>
@@ -3473,8 +3473,8 @@
         </p:blipFill>
         <p:spPr>
           <a:xfrm>
-            <a:off x="1928209" y="1005840"/>
-            <a:ext cx="8335276" cy="4754880"/>
+            <a:off x="1870879" y="1005840"/>
+            <a:ext cx="8449937" cy="4754880"/>
           </a:xfrm>
           <a:prstGeom prst="rect">
             <a:avLst/>
@@ -3635,8 +3635,8 @@
         </p:blipFill>
         <p:spPr>
           <a:xfrm>
-            <a:off x="1702995" y="1005840"/>
-            <a:ext cx="8785704" cy="4754880"/>
+            <a:off x="1648945" y="1005840"/>
+            <a:ext cx="8893804" cy="4754880"/>
           </a:xfrm>
           <a:prstGeom prst="rect">
             <a:avLst/>
@@ -3797,8 +3797,8 @@
         </p:blipFill>
         <p:spPr>
           <a:xfrm>
-            <a:off x="1994852" y="1005840"/>
-            <a:ext cx="8201990" cy="4754880"/>
+            <a:off x="1946069" y="1005840"/>
+            <a:ext cx="8299557" cy="4754880"/>
           </a:xfrm>
           <a:prstGeom prst="rect">
             <a:avLst/>

</xml_diff>